<commit_message>
Slido codes in decks; 300 Myr IGIMF galevo run
Co-Authored-By: Claude Opus 5.5 <noreply@anthropic.com>
Claude-Session: https://claude.ai/code/session_01WBTdaRnm2ChJRsu6zYFdBL
</commit_message>
<xml_diff>
--- a/slides/lecture2_chemical_evolution.pptx
+++ b/slides/lecture2_chemical_evolution.pptx
@@ -5530,8 +5530,8 @@
         </p:nvSpPr>
         <p:spPr>
           <a:xfrm>
-            <a:off x="731520" y="1828800"/>
-            <a:ext cx="10698480" cy="1463040"/>
+            <a:off x="731520" y="1463040"/>
+            <a:ext cx="10698480" cy="2011680"/>
           </a:xfrm>
           <a:prstGeom prst="rect">
             <a:avLst/>
@@ -5539,7 +5539,7 @@
           <a:noFill/>
         </p:spPr>
         <p:txBody>
-          <a:bodyPr wrap="square" anchor="t">
+          <a:bodyPr wrap="square" anchor="b">
             <a:spAutoFit/>
           </a:bodyPr>
           <a:lstStyle/>
@@ -5569,7 +5569,7 @@
         </p:nvSpPr>
         <p:spPr>
           <a:xfrm>
-            <a:off x="731520" y="3383280"/>
+            <a:off x="731520" y="3657600"/>
             <a:ext cx="10698480" cy="914400"/>
           </a:xfrm>
           <a:prstGeom prst="rect">
@@ -6179,7 +6179,7 @@
                 </a:solidFill>
                 <a:latin typeface="Montserrat"/>
               </a:rPr>
-              <a:t>slido.com  ·  #CODE</a:t>
+              <a:t>slido.com  ·  #1642685</a:t>
             </a:r>
           </a:p>
         </p:txBody>
@@ -6572,7 +6572,7 @@
                 </a:solidFill>
                 <a:latin typeface="Montserrat"/>
               </a:rPr>
-              <a:t>slido.com  ·  #CODE</a:t>
+              <a:t>slido.com  ·  #1642685</a:t>
             </a:r>
           </a:p>
         </p:txBody>
@@ -6983,7 +6983,7 @@
                 </a:solidFill>
                 <a:latin typeface="Montserrat"/>
               </a:rPr>
-              <a:t>slido.com  ·  #CODE</a:t>
+              <a:t>slido.com  ·  #1642685</a:t>
             </a:r>
           </a:p>
         </p:txBody>
@@ -7433,7 +7433,7 @@
                 </a:solidFill>
                 <a:latin typeface="Montserrat"/>
               </a:rPr>
-              <a:t>slido.com  ·  #CODE</a:t>
+              <a:t>slido.com  ·  #1642685</a:t>
             </a:r>
           </a:p>
         </p:txBody>
@@ -7794,7 +7794,7 @@
                 </a:solidFill>
                 <a:latin typeface="Montserrat"/>
               </a:rPr>
-              <a:t>slido.com  ·  #CODE</a:t>
+              <a:t>slido.com  ·  #1642685</a:t>
             </a:r>
           </a:p>
         </p:txBody>
@@ -8161,7 +8161,7 @@
                 </a:solidFill>
                 <a:latin typeface="Montserrat"/>
               </a:rPr>
-              <a:t>slido.com  ·  #CODE</a:t>
+              <a:t>slido.com  ·  #1642685</a:t>
             </a:r>
           </a:p>
         </p:txBody>
@@ -8528,7 +8528,7 @@
                 </a:solidFill>
                 <a:latin typeface="Montserrat"/>
               </a:rPr>
-              <a:t>slido.com  ·  #CODE</a:t>
+              <a:t>slido.com  ·  #1642685</a:t>
             </a:r>
           </a:p>
         </p:txBody>
@@ -8754,7 +8754,7 @@
                 </a:solidFill>
                 <a:latin typeface="Montserrat"/>
               </a:rPr>
-              <a:t>slido.com  ·  #CODE</a:t>
+              <a:t>slido.com  ·  #1642685</a:t>
             </a:r>
           </a:p>
         </p:txBody>
@@ -9291,7 +9291,7 @@
                 </a:solidFill>
                 <a:latin typeface="Montserrat"/>
               </a:rPr>
-              <a:t>slido.com  ·  #CODE</a:t>
+              <a:t>slido.com  ·  #1642685</a:t>
             </a:r>
           </a:p>
         </p:txBody>
@@ -9881,7 +9881,7 @@
                 </a:solidFill>
                 <a:latin typeface="Montserrat"/>
               </a:rPr>
-              <a:t>slido.com  ·  #CODE</a:t>
+              <a:t>slido.com  ·  #1642685</a:t>
             </a:r>
           </a:p>
         </p:txBody>

</xml_diff>

<commit_message>
Add 3 Gyr Kroupa galevo run and the galevo animation (A8); Lecture 2 deck with A8
Co-Authored-By: Claude Opus 5.5 <noreply@anthropic.com>
Claude-Session: https://claude.ai/code/session_01WBTdaRnm2ChJRsu6zYFdBL
</commit_message>
<xml_diff>
--- a/slides/lecture2_chemical_evolution.pptx
+++ b/slides/lecture2_chemical_evolution.pptx
@@ -7605,12 +7605,29 @@
         <p:nvPr/>
       </p:nvGrpSpPr>
       <p:grpSpPr/>
-      <p:sp>
-        <p:nvSpPr>
-          <p:cNvPr id="2" name="TextBox 1"/>
-          <p:cNvSpPr txBox="1"/>
-          <p:nvPr/>
-        </p:nvSpPr>
+      <p:pic>
+        <p:nvPicPr>
+          <p:cNvPr id="2" name="a8_galevo_tracks.mp4">
+            <a:hlinkClick r:id="" action="ppaction://media"/>
+          </p:cNvPr>
+          <p:cNvPicPr>
+            <a:picLocks noChangeAspect="1"/>
+          </p:cNvPicPr>
+          <p:nvPr>
+            <a:videoFile r:link="rId4"/>
+            <p:extLst>
+              <p:ext uri="{DAA4B4D4-6D71-4841-9C94-3DE7FCFB9230}">
+                <p14:media xmlns:p14="http://schemas.microsoft.com/office/powerpoint/2010/main" r:embed="rId3"/>
+              </p:ext>
+            </p:extLst>
+          </p:nvPr>
+        </p:nvPicPr>
+        <p:blipFill>
+          <a:blip r:embed="rId5"/>
+          <a:stretch>
+            <a:fillRect/>
+          </a:stretch>
+        </p:blipFill>
         <p:spPr>
           <a:xfrm>
             <a:off x="365760" y="182880"/>
@@ -7619,36 +7636,35 @@
           <a:prstGeom prst="rect">
             <a:avLst/>
           </a:prstGeom>
-          <a:noFill/>
-        </p:spPr>
-        <p:txBody>
-          <a:bodyPr wrap="square" anchor="t">
-            <a:spAutoFit/>
-          </a:bodyPr>
-          <a:lstStyle/>
-          <a:p>
-            <a:pPr algn="l">
-              <a:spcAft>
-                <a:spcPts val="720"/>
-              </a:spcAft>
-            </a:pPr>
-            <a:r>
-              <a:rPr sz="1600" b="0" i="0">
-                <a:solidFill>
-                  <a:srgbClr val="9A9AB5"/>
-                </a:solidFill>
-                <a:latin typeface="Montserrat"/>
-              </a:rPr>
-              <a:t>[missing: a8_galevo_tracks_final.png]</a:t>
-            </a:r>
-          </a:p>
-        </p:txBody>
-      </p:sp>
+        </p:spPr>
+      </p:pic>
     </p:spTree>
   </p:cSld>
   <p:clrMapOvr>
     <a:masterClrMapping/>
   </p:clrMapOvr>
+  <p:timing>
+    <p:tnLst>
+      <p:par>
+        <p:cTn id="1" dur="indefinite" restart="never" nodeType="tmRoot">
+          <p:childTnLst>
+            <p:video>
+              <p:cMediaNode vol="80000">
+                <p:cTn id="2" fill="hold" display="0">
+                  <p:stCondLst>
+                    <p:cond delay="indefinite"/>
+                  </p:stCondLst>
+                </p:cTn>
+                <p:tgtEl>
+                  <p:spTgt spid="2"/>
+                </p:tgtEl>
+              </p:cMediaNode>
+            </p:video>
+          </p:childTnLst>
+        </p:cTn>
+      </p:par>
+    </p:tnLst>
+  </p:timing>
 </p:sld>
 </file>
 

</xml_diff>